<commit_message>
Add Modifications from Sally's Meeting
</commit_message>
<xml_diff>
--- a/Documentations/presentation V1.pptx
+++ b/Documentations/presentation V1.pptx
@@ -5,7 +5,7 @@
     <p:sldMasterId id="2147483674" r:id="rId4"/>
   </p:sldMasterIdLst>
   <p:notesMasterIdLst>
-    <p:notesMasterId r:id="rId27"/>
+    <p:notesMasterId r:id="rId28"/>
   </p:notesMasterIdLst>
   <p:sldIdLst>
     <p:sldId id="256" r:id="rId5"/>
@@ -28,37 +28,38 @@
     <p:sldId id="313" r:id="rId22"/>
     <p:sldId id="310" r:id="rId23"/>
     <p:sldId id="311" r:id="rId24"/>
-    <p:sldId id="257" r:id="rId25"/>
-    <p:sldId id="314" r:id="rId26"/>
+    <p:sldId id="318" r:id="rId25"/>
+    <p:sldId id="257" r:id="rId26"/>
+    <p:sldId id="314" r:id="rId27"/>
   </p:sldIdLst>
   <p:sldSz cx="9144000" cy="5143500" type="screen16x9"/>
   <p:notesSz cx="6858000" cy="9144000"/>
   <p:embeddedFontLst>
     <p:embeddedFont>
-      <p:font typeface="DM Sans" panose="020B0604020202020204" charset="0"/>
-      <p:regular r:id="rId28"/>
-      <p:bold r:id="rId29"/>
-      <p:italic r:id="rId30"/>
-      <p:boldItalic r:id="rId31"/>
+      <p:font typeface="DM Sans" pitchFamily="2" charset="0"/>
+      <p:regular r:id="rId29"/>
+      <p:bold r:id="rId30"/>
+      <p:italic r:id="rId31"/>
+      <p:boldItalic r:id="rId32"/>
     </p:embeddedFont>
     <p:embeddedFont>
       <p:font typeface="Lato" panose="020F0502020204030203" pitchFamily="34" charset="0"/>
-      <p:regular r:id="rId32"/>
-      <p:bold r:id="rId33"/>
-      <p:italic r:id="rId34"/>
-      <p:boldItalic r:id="rId35"/>
+      <p:regular r:id="rId33"/>
+      <p:bold r:id="rId34"/>
+      <p:italic r:id="rId35"/>
+      <p:boldItalic r:id="rId36"/>
     </p:embeddedFont>
     <p:embeddedFont>
       <p:font typeface="Montserrat" panose="00000500000000000000" pitchFamily="2" charset="0"/>
-      <p:regular r:id="rId36"/>
-      <p:bold r:id="rId37"/>
-      <p:italic r:id="rId38"/>
-      <p:boldItalic r:id="rId39"/>
+      <p:regular r:id="rId37"/>
+      <p:bold r:id="rId38"/>
+      <p:italic r:id="rId39"/>
+      <p:boldItalic r:id="rId40"/>
     </p:embeddedFont>
     <p:embeddedFont>
       <p:font typeface="Montserrat ExtraBold" panose="00000900000000000000" pitchFamily="2" charset="0"/>
-      <p:bold r:id="rId40"/>
-      <p:boldItalic r:id="rId41"/>
+      <p:bold r:id="rId41"/>
+      <p:boldItalic r:id="rId42"/>
     </p:embeddedFont>
   </p:embeddedFontLst>
   <p:defaultTextStyle>
@@ -2300,6 +2301,133 @@
   <p:cSld>
     <p:spTree>
       <p:nvGrpSpPr>
+        <p:cNvPr id="1" name="Shape 310">
+          <a:extLst>
+            <a:ext uri="{FF2B5EF4-FFF2-40B4-BE49-F238E27FC236}">
+              <a16:creationId xmlns:a16="http://schemas.microsoft.com/office/drawing/2014/main" id="{9747235F-1F6F-292F-B075-4D17AE6F4EDD}"/>
+            </a:ext>
+          </a:extLst>
+        </p:cNvPr>
+        <p:cNvGrpSpPr/>
+        <p:nvPr/>
+      </p:nvGrpSpPr>
+      <p:grpSpPr>
+        <a:xfrm>
+          <a:off x="0" y="0"/>
+          <a:ext cx="0" cy="0"/>
+          <a:chOff x="0" y="0"/>
+          <a:chExt cx="0" cy="0"/>
+        </a:xfrm>
+      </p:grpSpPr>
+      <p:sp>
+        <p:nvSpPr>
+          <p:cNvPr id="311" name="Google Shape;311;g54dda1946d_6_322:notes">
+            <a:extLst>
+              <a:ext uri="{FF2B5EF4-FFF2-40B4-BE49-F238E27FC236}">
+                <a16:creationId xmlns:a16="http://schemas.microsoft.com/office/drawing/2014/main" id="{B06ACC7B-CCC5-9974-CB49-DD5F6589692F}"/>
+              </a:ext>
+            </a:extLst>
+          </p:cNvPr>
+          <p:cNvSpPr>
+            <a:spLocks noGrp="1" noRot="1" noChangeAspect="1"/>
+          </p:cNvSpPr>
+          <p:nvPr>
+            <p:ph type="sldImg" idx="2"/>
+          </p:nvPr>
+        </p:nvSpPr>
+        <p:spPr>
+          <a:xfrm>
+            <a:off x="381000" y="685800"/>
+            <a:ext cx="6096000" cy="3429000"/>
+          </a:xfrm>
+          <a:custGeom>
+            <a:avLst/>
+            <a:gdLst/>
+            <a:ahLst/>
+            <a:cxnLst/>
+            <a:rect l="l" t="t" r="r" b="b"/>
+            <a:pathLst>
+              <a:path w="120000" h="120000" extrusionOk="0">
+                <a:moveTo>
+                  <a:pt x="0" y="0"/>
+                </a:moveTo>
+                <a:lnTo>
+                  <a:pt x="120000" y="0"/>
+                </a:lnTo>
+                <a:lnTo>
+                  <a:pt x="120000" y="120000"/>
+                </a:lnTo>
+                <a:lnTo>
+                  <a:pt x="0" y="120000"/>
+                </a:lnTo>
+                <a:close/>
+              </a:path>
+            </a:pathLst>
+          </a:custGeom>
+        </p:spPr>
+      </p:sp>
+      <p:sp>
+        <p:nvSpPr>
+          <p:cNvPr id="312" name="Google Shape;312;g54dda1946d_6_322:notes">
+            <a:extLst>
+              <a:ext uri="{FF2B5EF4-FFF2-40B4-BE49-F238E27FC236}">
+                <a16:creationId xmlns:a16="http://schemas.microsoft.com/office/drawing/2014/main" id="{EAB6CDA7-16E4-336B-9CAA-5CDC5817E715}"/>
+              </a:ext>
+            </a:extLst>
+          </p:cNvPr>
+          <p:cNvSpPr txBox="1">
+            <a:spLocks noGrp="1"/>
+          </p:cNvSpPr>
+          <p:nvPr>
+            <p:ph type="body" idx="1"/>
+          </p:nvPr>
+        </p:nvSpPr>
+        <p:spPr>
+          <a:xfrm>
+            <a:off x="685800" y="4343400"/>
+            <a:ext cx="5486400" cy="4114800"/>
+          </a:xfrm>
+          <a:prstGeom prst="rect">
+            <a:avLst/>
+          </a:prstGeom>
+        </p:spPr>
+        <p:txBody>
+          <a:bodyPr spcFirstLastPara="1" wrap="square" lIns="91425" tIns="91425" rIns="91425" bIns="91425" anchor="t" anchorCtr="0">
+            <a:noAutofit/>
+          </a:bodyPr>
+          <a:lstStyle/>
+          <a:p>
+            <a:pPr marL="0" lvl="0" indent="0" algn="l" rtl="0">
+              <a:spcBef>
+                <a:spcPts val="0"/>
+              </a:spcBef>
+              <a:spcAft>
+                <a:spcPts val="0"/>
+              </a:spcAft>
+              <a:buNone/>
+            </a:pPr>
+            <a:endParaRPr/>
+          </a:p>
+        </p:txBody>
+      </p:sp>
+    </p:spTree>
+    <p:extLst>
+      <p:ext uri="{BB962C8B-B14F-4D97-AF65-F5344CB8AC3E}">
+        <p14:creationId xmlns:p14="http://schemas.microsoft.com/office/powerpoint/2010/main" val="101489006"/>
+      </p:ext>
+    </p:extLst>
+  </p:cSld>
+  <p:clrMapOvr>
+    <a:masterClrMapping/>
+  </p:clrMapOvr>
+</p:notes>
+</file>
+
+<file path=ppt/notesSlides/notesSlide22.xml><?xml version="1.0" encoding="utf-8"?>
+<p:notes xmlns:a="http://schemas.openxmlformats.org/drawingml/2006/main" xmlns:r="http://schemas.openxmlformats.org/officeDocument/2006/relationships" xmlns:p="http://schemas.openxmlformats.org/presentationml/2006/main" showMasterSp="0" showMasterPhAnim="0">
+  <p:cSld>
+    <p:spTree>
+      <p:nvGrpSpPr>
         <p:cNvPr id="1" name="Shape 284"/>
         <p:cNvGrpSpPr/>
         <p:nvPr/>
@@ -2404,7 +2532,7 @@
 </p:notes>
 </file>
 
-<file path=ppt/notesSlides/notesSlide22.xml><?xml version="1.0" encoding="utf-8"?>
+<file path=ppt/notesSlides/notesSlide23.xml><?xml version="1.0" encoding="utf-8"?>
 <p:notes xmlns:a="http://schemas.openxmlformats.org/drawingml/2006/main" xmlns:r="http://schemas.openxmlformats.org/officeDocument/2006/relationships" xmlns:p="http://schemas.openxmlformats.org/presentationml/2006/main" showMasterSp="0" showMasterPhAnim="0">
   <p:cSld>
     <p:spTree>
@@ -13949,7 +14077,7 @@
               <a:rPr lang="en-US" sz="2000" b="1" dirty="0"/>
               <a:t>NP-hard problem</a:t>
             </a:r>
-            <a:endParaRPr sz="2000" dirty="0"/>
+            <a:endParaRPr sz="1000" dirty="0"/>
           </a:p>
         </p:txBody>
       </p:sp>
@@ -18002,7 +18130,7 @@
                   <a:schemeClr val="tx1"/>
                 </a:solidFill>
               </a:rPr>
-              <a:t>Stadium Sharing</a:t>
+              <a:t>Shared Resources</a:t>
             </a:r>
             <a:endParaRPr sz="2000" b="1" dirty="0">
               <a:solidFill>
@@ -18053,8 +18181,15 @@
                 </a:solidFill>
                 <a:latin typeface="DM Sans" pitchFamily="2" charset="0"/>
               </a:rPr>
-              <a:t>Unlike Europe, multiple teams share "Cairo International" and "Borg Al-Arab," creating bottlenecks</a:t>
+              <a:t>Multiple teams share "Cairo International" and "Borg Al-Arab," creating bottlenecks</a:t>
             </a:r>
+          </a:p>
+          <a:p>
+            <a:pPr lvl="0">
+              <a:lnSpc>
+                <a:spcPct val="115000"/>
+              </a:lnSpc>
+            </a:pPr>
             <a:endParaRPr dirty="0">
               <a:solidFill>
                 <a:schemeClr val="tx1"/>
@@ -18105,7 +18240,7 @@
                   <a:schemeClr val="tx1"/>
                 </a:solidFill>
               </a:rPr>
-              <a:t>CAF Uncertainty</a:t>
+              <a:t>CAF Conflict</a:t>
             </a:r>
             <a:endParaRPr sz="2000" b="1" dirty="0">
               <a:solidFill>
@@ -20250,7 +20385,7 @@
             <a:pPr marL="0" lvl="0" indent="0"/>
             <a:r>
               <a:rPr lang="en-US" dirty="0"/>
-              <a:t>KM distance between every stadium (for travel costs)</a:t>
+              <a:t>KM distance between every 2 nodes on a network (for travel costs)</a:t>
             </a:r>
             <a:endParaRPr dirty="0"/>
           </a:p>
@@ -26898,7 +27033,7 @@
             </a:pPr>
             <a:r>
               <a:rPr lang="en-US" sz="1500" b="1" dirty="0"/>
-              <a:t>Smart Blocking: </a:t>
+              <a:t>Blocking: </a:t>
             </a:r>
             <a:r>
               <a:rPr lang="en-US" sz="1500" dirty="0"/>
@@ -29522,7 +29657,7 @@
             </a:pPr>
             <a:r>
               <a:rPr lang="en-US" sz="1800" b="1" dirty="0"/>
-              <a:t>Next Phase: Formulating the Multi-Objective Integer Linear Programming (ILP) Model to generate the schedule.</a:t>
+              <a:t>Next Phase: Formulating the Integer Linear Programming (ILP) Model to generate the schedule.</a:t>
             </a:r>
             <a:endParaRPr kumimoji="0" lang="en-US" altLang="en-US" sz="1800" b="0" i="0" u="none" strike="noStrike" cap="none" normalizeH="0" baseline="0" dirty="0">
               <a:ln>
@@ -29551,6 +29686,790 @@
 </file>
 
 <file path=ppt/slides/slide21.xml><?xml version="1.0" encoding="utf-8"?>
+<p:sld xmlns:a="http://schemas.openxmlformats.org/drawingml/2006/main" xmlns:r="http://schemas.openxmlformats.org/officeDocument/2006/relationships" xmlns:p="http://schemas.openxmlformats.org/presentationml/2006/main">
+  <p:cSld>
+    <p:spTree>
+      <p:nvGrpSpPr>
+        <p:cNvPr id="1" name="Shape 313">
+          <a:extLst>
+            <a:ext uri="{FF2B5EF4-FFF2-40B4-BE49-F238E27FC236}">
+              <a16:creationId xmlns:a16="http://schemas.microsoft.com/office/drawing/2014/main" id="{C6268C87-CBD2-E48E-BBEE-2108CA5CB5EE}"/>
+            </a:ext>
+          </a:extLst>
+        </p:cNvPr>
+        <p:cNvGrpSpPr/>
+        <p:nvPr/>
+      </p:nvGrpSpPr>
+      <p:grpSpPr>
+        <a:xfrm>
+          <a:off x="0" y="0"/>
+          <a:ext cx="0" cy="0"/>
+          <a:chOff x="0" y="0"/>
+          <a:chExt cx="0" cy="0"/>
+        </a:xfrm>
+      </p:grpSpPr>
+      <p:sp>
+        <p:nvSpPr>
+          <p:cNvPr id="314" name="Google Shape;314;p32">
+            <a:extLst>
+              <a:ext uri="{FF2B5EF4-FFF2-40B4-BE49-F238E27FC236}">
+                <a16:creationId xmlns:a16="http://schemas.microsoft.com/office/drawing/2014/main" id="{422328E0-39E0-E94E-33E2-2A67E6782902}"/>
+              </a:ext>
+            </a:extLst>
+          </p:cNvPr>
+          <p:cNvSpPr txBox="1">
+            <a:spLocks noGrp="1"/>
+          </p:cNvSpPr>
+          <p:nvPr>
+            <p:ph type="title"/>
+          </p:nvPr>
+        </p:nvSpPr>
+        <p:spPr>
+          <a:xfrm>
+            <a:off x="720000" y="445025"/>
+            <a:ext cx="7704000" cy="572700"/>
+          </a:xfrm>
+          <a:prstGeom prst="rect">
+            <a:avLst/>
+          </a:prstGeom>
+        </p:spPr>
+        <p:txBody>
+          <a:bodyPr spcFirstLastPara="1" wrap="square" lIns="91425" tIns="91425" rIns="91425" bIns="91425" anchor="t" anchorCtr="0">
+            <a:noAutofit/>
+          </a:bodyPr>
+          <a:lstStyle/>
+          <a:p>
+            <a:pPr lvl="0"/>
+            <a:r>
+              <a:rPr lang="en-US" dirty="0"/>
+              <a:t>References</a:t>
+            </a:r>
+            <a:endParaRPr dirty="0"/>
+          </a:p>
+        </p:txBody>
+      </p:sp>
+      <p:graphicFrame>
+        <p:nvGraphicFramePr>
+          <p:cNvPr id="5" name="Table 4">
+            <a:extLst>
+              <a:ext uri="{FF2B5EF4-FFF2-40B4-BE49-F238E27FC236}">
+                <a16:creationId xmlns:a16="http://schemas.microsoft.com/office/drawing/2014/main" id="{8B41EDEC-0304-80B9-5928-6F85AD383B56}"/>
+              </a:ext>
+            </a:extLst>
+          </p:cNvPr>
+          <p:cNvGraphicFramePr>
+            <a:graphicFrameLocks noGrp="1"/>
+          </p:cNvGraphicFramePr>
+          <p:nvPr>
+            <p:extLst>
+              <p:ext uri="{D42A27DB-BD31-4B8C-83A1-F6EECF244321}">
+                <p14:modId xmlns:p14="http://schemas.microsoft.com/office/powerpoint/2010/main" val="4246598501"/>
+              </p:ext>
+            </p:extLst>
+          </p:nvPr>
+        </p:nvGraphicFramePr>
+        <p:xfrm>
+          <a:off x="720000" y="1152527"/>
+          <a:ext cx="7836702" cy="3049686"/>
+        </p:xfrm>
+        <a:graphic>
+          <a:graphicData uri="http://schemas.openxmlformats.org/drawingml/2006/table">
+            <a:tbl>
+              <a:tblPr firstRow="1" firstCol="1" bandRow="1"/>
+              <a:tblGrid>
+                <a:gridCol w="239005">
+                  <a:extLst>
+                    <a:ext uri="{9D8B030D-6E8A-4147-A177-3AD203B41FA5}">
+                      <a16:colId xmlns:a16="http://schemas.microsoft.com/office/drawing/2014/main" val="4294718165"/>
+                    </a:ext>
+                  </a:extLst>
+                </a:gridCol>
+                <a:gridCol w="7597697">
+                  <a:extLst>
+                    <a:ext uri="{9D8B030D-6E8A-4147-A177-3AD203B41FA5}">
+                      <a16:colId xmlns:a16="http://schemas.microsoft.com/office/drawing/2014/main" val="1349942756"/>
+                    </a:ext>
+                  </a:extLst>
+                </a:gridCol>
+              </a:tblGrid>
+              <a:tr h="508281">
+                <a:tc>
+                  <a:txBody>
+                    <a:bodyPr/>
+                    <a:lstStyle/>
+                    <a:p>
+                      <a:pPr marL="0" marR="0">
+                        <a:lnSpc>
+                          <a:spcPct val="115000"/>
+                        </a:lnSpc>
+                        <a:spcAft>
+                          <a:spcPts val="800"/>
+                        </a:spcAft>
+                        <a:buNone/>
+                      </a:pPr>
+                      <a:r>
+                        <a:rPr lang="en-US" sz="1000" b="1" dirty="0">
+                          <a:effectLst/>
+                          <a:latin typeface="DM Sans" pitchFamily="2" charset="0"/>
+                          <a:ea typeface="Calibri" panose="020F0502020204030204" pitchFamily="34" charset="0"/>
+                          <a:cs typeface="Arial" panose="020B0604020202020204" pitchFamily="34" charset="0"/>
+                        </a:rPr>
+                        <a:t>[1] </a:t>
+                      </a:r>
+                    </a:p>
+                  </a:txBody>
+                  <a:tcPr marL="6940" marR="6940" marT="6940" marB="6940">
+                    <a:lnL>
+                      <a:noFill/>
+                    </a:lnL>
+                    <a:lnR>
+                      <a:noFill/>
+                    </a:lnR>
+                    <a:lnT>
+                      <a:noFill/>
+                    </a:lnT>
+                    <a:lnB>
+                      <a:noFill/>
+                    </a:lnB>
+                    <a:noFill/>
+                  </a:tcPr>
+                </a:tc>
+                <a:tc>
+                  <a:txBody>
+                    <a:bodyPr/>
+                    <a:lstStyle/>
+                    <a:p>
+                      <a:pPr marL="0" marR="0">
+                        <a:lnSpc>
+                          <a:spcPct val="115000"/>
+                        </a:lnSpc>
+                        <a:spcAft>
+                          <a:spcPts val="800"/>
+                        </a:spcAft>
+                        <a:buNone/>
+                      </a:pPr>
+                      <a:r>
+                        <a:rPr lang="en-US" sz="1000" b="1" dirty="0">
+                          <a:effectLst/>
+                          <a:latin typeface="DM Sans" pitchFamily="2" charset="0"/>
+                          <a:ea typeface="Calibri" panose="020F0502020204030204" pitchFamily="34" charset="0"/>
+                          <a:cs typeface="Arial" panose="020B0604020202020204" pitchFamily="34" charset="0"/>
+                        </a:rPr>
+                        <a:t>R. V. Rasmussen and M. A. Trick, "Round robin scheduling – a survey," </a:t>
+                      </a:r>
+                      <a:r>
+                        <a:rPr lang="en-US" sz="1000" b="1" i="1" dirty="0">
+                          <a:effectLst/>
+                          <a:latin typeface="DM Sans" pitchFamily="2" charset="0"/>
+                          <a:ea typeface="Calibri" panose="020F0502020204030204" pitchFamily="34" charset="0"/>
+                          <a:cs typeface="Arial" panose="020B0604020202020204" pitchFamily="34" charset="0"/>
+                        </a:rPr>
+                        <a:t>European Journal of Operational Research, </a:t>
+                      </a:r>
+                      <a:r>
+                        <a:rPr lang="en-US" sz="1000" b="1" dirty="0">
+                          <a:effectLst/>
+                          <a:latin typeface="DM Sans" pitchFamily="2" charset="0"/>
+                          <a:ea typeface="Calibri" panose="020F0502020204030204" pitchFamily="34" charset="0"/>
+                          <a:cs typeface="Arial" panose="020B0604020202020204" pitchFamily="34" charset="0"/>
+                        </a:rPr>
+                        <a:t>2008. </a:t>
+                      </a:r>
+                    </a:p>
+                  </a:txBody>
+                  <a:tcPr marL="6940" marR="6940" marT="6940" marB="6940">
+                    <a:lnL>
+                      <a:noFill/>
+                    </a:lnL>
+                    <a:lnR>
+                      <a:noFill/>
+                    </a:lnR>
+                    <a:lnT>
+                      <a:noFill/>
+                    </a:lnT>
+                    <a:lnB>
+                      <a:noFill/>
+                    </a:lnB>
+                    <a:noFill/>
+                  </a:tcPr>
+                </a:tc>
+                <a:extLst>
+                  <a:ext uri="{0D108BD9-81ED-4DB2-BD59-A6C34878D82A}">
+                    <a16:rowId xmlns:a16="http://schemas.microsoft.com/office/drawing/2014/main" val="2049997458"/>
+                  </a:ext>
+                </a:extLst>
+              </a:tr>
+              <a:tr h="508281">
+                <a:tc>
+                  <a:txBody>
+                    <a:bodyPr/>
+                    <a:lstStyle/>
+                    <a:p>
+                      <a:pPr marL="0" marR="0">
+                        <a:lnSpc>
+                          <a:spcPct val="115000"/>
+                        </a:lnSpc>
+                        <a:spcAft>
+                          <a:spcPts val="800"/>
+                        </a:spcAft>
+                        <a:buNone/>
+                      </a:pPr>
+                      <a:r>
+                        <a:rPr lang="en-US" sz="1000" b="1" dirty="0">
+                          <a:effectLst/>
+                          <a:latin typeface="DM Sans" pitchFamily="2" charset="0"/>
+                          <a:ea typeface="Calibri" panose="020F0502020204030204" pitchFamily="34" charset="0"/>
+                          <a:cs typeface="Arial" panose="020B0604020202020204" pitchFamily="34" charset="0"/>
+                        </a:rPr>
+                        <a:t>[2] </a:t>
+                      </a:r>
+                    </a:p>
+                  </a:txBody>
+                  <a:tcPr marL="6940" marR="6940" marT="6940" marB="6940">
+                    <a:lnL>
+                      <a:noFill/>
+                    </a:lnL>
+                    <a:lnR>
+                      <a:noFill/>
+                    </a:lnR>
+                    <a:lnT>
+                      <a:noFill/>
+                    </a:lnT>
+                    <a:lnB>
+                      <a:noFill/>
+                    </a:lnB>
+                    <a:noFill/>
+                  </a:tcPr>
+                </a:tc>
+                <a:tc>
+                  <a:txBody>
+                    <a:bodyPr/>
+                    <a:lstStyle/>
+                    <a:p>
+                      <a:pPr marL="0" marR="0">
+                        <a:lnSpc>
+                          <a:spcPct val="115000"/>
+                        </a:lnSpc>
+                        <a:spcAft>
+                          <a:spcPts val="800"/>
+                        </a:spcAft>
+                        <a:buNone/>
+                      </a:pPr>
+                      <a:r>
+                        <a:rPr lang="en-US" sz="1000" b="1" dirty="0">
+                          <a:effectLst/>
+                          <a:latin typeface="DM Sans" pitchFamily="2" charset="0"/>
+                          <a:ea typeface="Calibri" panose="020F0502020204030204" pitchFamily="34" charset="0"/>
+                          <a:cs typeface="Arial" panose="020B0604020202020204" pitchFamily="34" charset="0"/>
+                        </a:rPr>
+                        <a:t>D. Van Bulck, D. Goossens and F. </a:t>
+                      </a:r>
+                      <a:r>
+                        <a:rPr lang="en-US" sz="1000" b="1" dirty="0" err="1">
+                          <a:effectLst/>
+                          <a:latin typeface="DM Sans" pitchFamily="2" charset="0"/>
+                          <a:ea typeface="Calibri" panose="020F0502020204030204" pitchFamily="34" charset="0"/>
+                          <a:cs typeface="Arial" panose="020B0604020202020204" pitchFamily="34" charset="0"/>
+                        </a:rPr>
+                        <a:t>Spieksma</a:t>
+                      </a:r>
+                      <a:r>
+                        <a:rPr lang="en-US" sz="1000" b="1" dirty="0">
+                          <a:effectLst/>
+                          <a:latin typeface="DM Sans" pitchFamily="2" charset="0"/>
+                          <a:ea typeface="Calibri" panose="020F0502020204030204" pitchFamily="34" charset="0"/>
+                          <a:cs typeface="Arial" panose="020B0604020202020204" pitchFamily="34" charset="0"/>
+                        </a:rPr>
+                        <a:t>, "Integer programming models for round robin tournaments," </a:t>
+                      </a:r>
+                      <a:r>
+                        <a:rPr lang="en-US" sz="1000" b="1" i="1" dirty="0">
+                          <a:effectLst/>
+                          <a:latin typeface="DM Sans" pitchFamily="2" charset="0"/>
+                          <a:ea typeface="Calibri" panose="020F0502020204030204" pitchFamily="34" charset="0"/>
+                          <a:cs typeface="Arial" panose="020B0604020202020204" pitchFamily="34" charset="0"/>
+                        </a:rPr>
+                        <a:t>European Journal of Operational Research, </a:t>
+                      </a:r>
+                      <a:r>
+                        <a:rPr lang="en-US" sz="1000" b="1" dirty="0">
+                          <a:effectLst/>
+                          <a:latin typeface="DM Sans" pitchFamily="2" charset="0"/>
+                          <a:ea typeface="Calibri" panose="020F0502020204030204" pitchFamily="34" charset="0"/>
+                          <a:cs typeface="Arial" panose="020B0604020202020204" pitchFamily="34" charset="0"/>
+                        </a:rPr>
+                        <a:t>2023. </a:t>
+                      </a:r>
+                    </a:p>
+                  </a:txBody>
+                  <a:tcPr marL="6940" marR="6940" marT="6940" marB="6940">
+                    <a:lnL>
+                      <a:noFill/>
+                    </a:lnL>
+                    <a:lnR>
+                      <a:noFill/>
+                    </a:lnR>
+                    <a:lnT>
+                      <a:noFill/>
+                    </a:lnT>
+                    <a:lnB>
+                      <a:noFill/>
+                    </a:lnB>
+                    <a:noFill/>
+                  </a:tcPr>
+                </a:tc>
+                <a:extLst>
+                  <a:ext uri="{0D108BD9-81ED-4DB2-BD59-A6C34878D82A}">
+                    <a16:rowId xmlns:a16="http://schemas.microsoft.com/office/drawing/2014/main" val="673108309"/>
+                  </a:ext>
+                </a:extLst>
+              </a:tr>
+              <a:tr h="508281">
+                <a:tc>
+                  <a:txBody>
+                    <a:bodyPr/>
+                    <a:lstStyle/>
+                    <a:p>
+                      <a:pPr marL="0" marR="0">
+                        <a:lnSpc>
+                          <a:spcPct val="115000"/>
+                        </a:lnSpc>
+                        <a:spcAft>
+                          <a:spcPts val="800"/>
+                        </a:spcAft>
+                        <a:buNone/>
+                      </a:pPr>
+                      <a:r>
+                        <a:rPr lang="en-US" sz="1000" b="1" dirty="0">
+                          <a:effectLst/>
+                          <a:latin typeface="DM Sans" pitchFamily="2" charset="0"/>
+                          <a:ea typeface="Calibri" panose="020F0502020204030204" pitchFamily="34" charset="0"/>
+                          <a:cs typeface="Arial" panose="020B0604020202020204" pitchFamily="34" charset="0"/>
+                        </a:rPr>
+                        <a:t>[3] </a:t>
+                      </a:r>
+                    </a:p>
+                  </a:txBody>
+                  <a:tcPr marL="6940" marR="6940" marT="6940" marB="6940">
+                    <a:lnL>
+                      <a:noFill/>
+                    </a:lnL>
+                    <a:lnR>
+                      <a:noFill/>
+                    </a:lnR>
+                    <a:lnT>
+                      <a:noFill/>
+                    </a:lnT>
+                    <a:lnB>
+                      <a:noFill/>
+                    </a:lnB>
+                    <a:noFill/>
+                  </a:tcPr>
+                </a:tc>
+                <a:tc>
+                  <a:txBody>
+                    <a:bodyPr/>
+                    <a:lstStyle/>
+                    <a:p>
+                      <a:pPr marL="0" marR="0">
+                        <a:lnSpc>
+                          <a:spcPct val="115000"/>
+                        </a:lnSpc>
+                        <a:spcAft>
+                          <a:spcPts val="800"/>
+                        </a:spcAft>
+                        <a:buNone/>
+                      </a:pPr>
+                      <a:r>
+                        <a:rPr lang="en-US" sz="1000" b="1" dirty="0">
+                          <a:effectLst/>
+                          <a:latin typeface="DM Sans" pitchFamily="2" charset="0"/>
+                          <a:ea typeface="Calibri" panose="020F0502020204030204" pitchFamily="34" charset="0"/>
+                          <a:cs typeface="Arial" panose="020B0604020202020204" pitchFamily="34" charset="0"/>
+                        </a:rPr>
+                        <a:t>P. Staats, "Generic Scheduling of Sports Tournaments," Utrecht University, Utrecht, 2009.</a:t>
+                      </a:r>
+                    </a:p>
+                  </a:txBody>
+                  <a:tcPr marL="6940" marR="6940" marT="6940" marB="6940">
+                    <a:lnL>
+                      <a:noFill/>
+                    </a:lnL>
+                    <a:lnR>
+                      <a:noFill/>
+                    </a:lnR>
+                    <a:lnT>
+                      <a:noFill/>
+                    </a:lnT>
+                    <a:lnB>
+                      <a:noFill/>
+                    </a:lnB>
+                    <a:noFill/>
+                  </a:tcPr>
+                </a:tc>
+                <a:extLst>
+                  <a:ext uri="{0D108BD9-81ED-4DB2-BD59-A6C34878D82A}">
+                    <a16:rowId xmlns:a16="http://schemas.microsoft.com/office/drawing/2014/main" val="2754345337"/>
+                  </a:ext>
+                </a:extLst>
+              </a:tr>
+              <a:tr h="508281">
+                <a:tc>
+                  <a:txBody>
+                    <a:bodyPr/>
+                    <a:lstStyle/>
+                    <a:p>
+                      <a:pPr marL="0" marR="0">
+                        <a:lnSpc>
+                          <a:spcPct val="115000"/>
+                        </a:lnSpc>
+                        <a:spcAft>
+                          <a:spcPts val="800"/>
+                        </a:spcAft>
+                        <a:buNone/>
+                      </a:pPr>
+                      <a:r>
+                        <a:rPr lang="en-US" sz="1000" b="1" dirty="0">
+                          <a:effectLst/>
+                          <a:latin typeface="DM Sans" pitchFamily="2" charset="0"/>
+                          <a:ea typeface="Calibri" panose="020F0502020204030204" pitchFamily="34" charset="0"/>
+                          <a:cs typeface="Arial" panose="020B0604020202020204" pitchFamily="34" charset="0"/>
+                        </a:rPr>
+                        <a:t>[4] </a:t>
+                      </a:r>
+                    </a:p>
+                  </a:txBody>
+                  <a:tcPr marL="6940" marR="6940" marT="6940" marB="6940">
+                    <a:lnL>
+                      <a:noFill/>
+                    </a:lnL>
+                    <a:lnR>
+                      <a:noFill/>
+                    </a:lnR>
+                    <a:lnT>
+                      <a:noFill/>
+                    </a:lnT>
+                    <a:lnB>
+                      <a:noFill/>
+                    </a:lnB>
+                    <a:noFill/>
+                  </a:tcPr>
+                </a:tc>
+                <a:tc>
+                  <a:txBody>
+                    <a:bodyPr/>
+                    <a:lstStyle/>
+                    <a:p>
+                      <a:pPr marL="0" marR="0">
+                        <a:lnSpc>
+                          <a:spcPct val="115000"/>
+                        </a:lnSpc>
+                        <a:spcAft>
+                          <a:spcPts val="800"/>
+                        </a:spcAft>
+                        <a:buNone/>
+                      </a:pPr>
+                      <a:r>
+                        <a:rPr lang="en-US" sz="1000" b="1" dirty="0">
+                          <a:effectLst/>
+                          <a:latin typeface="DM Sans" pitchFamily="2" charset="0"/>
+                          <a:ea typeface="Calibri" panose="020F0502020204030204" pitchFamily="34" charset="0"/>
+                          <a:cs typeface="Arial" panose="020B0604020202020204" pitchFamily="34" charset="0"/>
+                        </a:rPr>
+                        <a:t>D. R. Goossens and F. C. R. </a:t>
+                      </a:r>
+                      <a:r>
+                        <a:rPr lang="en-US" sz="1000" b="1" dirty="0" err="1">
+                          <a:effectLst/>
+                          <a:latin typeface="DM Sans" pitchFamily="2" charset="0"/>
+                          <a:ea typeface="Calibri" panose="020F0502020204030204" pitchFamily="34" charset="0"/>
+                          <a:cs typeface="Arial" panose="020B0604020202020204" pitchFamily="34" charset="0"/>
+                        </a:rPr>
+                        <a:t>Spieksma</a:t>
+                      </a:r>
+                      <a:r>
+                        <a:rPr lang="en-US" sz="1000" b="1" dirty="0">
+                          <a:effectLst/>
+                          <a:latin typeface="DM Sans" pitchFamily="2" charset="0"/>
+                          <a:ea typeface="Calibri" panose="020F0502020204030204" pitchFamily="34" charset="0"/>
+                          <a:cs typeface="Arial" panose="020B0604020202020204" pitchFamily="34" charset="0"/>
+                        </a:rPr>
+                        <a:t>, "Soccer schedules in Europe: an overview," </a:t>
+                      </a:r>
+                      <a:r>
+                        <a:rPr lang="en-US" sz="1000" b="1" i="1" dirty="0">
+                          <a:effectLst/>
+                          <a:latin typeface="DM Sans" pitchFamily="2" charset="0"/>
+                          <a:ea typeface="Calibri" panose="020F0502020204030204" pitchFamily="34" charset="0"/>
+                          <a:cs typeface="Arial" panose="020B0604020202020204" pitchFamily="34" charset="0"/>
+                        </a:rPr>
+                        <a:t>Journal of Scheduling, </a:t>
+                      </a:r>
+                      <a:r>
+                        <a:rPr lang="en-US" sz="1000" b="1" dirty="0">
+                          <a:effectLst/>
+                          <a:latin typeface="DM Sans" pitchFamily="2" charset="0"/>
+                          <a:ea typeface="Calibri" panose="020F0502020204030204" pitchFamily="34" charset="0"/>
+                          <a:cs typeface="Arial" panose="020B0604020202020204" pitchFamily="34" charset="0"/>
+                        </a:rPr>
+                        <a:t>vol. 15, no. 5, pp. 641-651, 2012. </a:t>
+                      </a:r>
+                    </a:p>
+                  </a:txBody>
+                  <a:tcPr marL="6940" marR="6940" marT="6940" marB="6940">
+                    <a:lnL>
+                      <a:noFill/>
+                    </a:lnL>
+                    <a:lnR>
+                      <a:noFill/>
+                    </a:lnR>
+                    <a:lnT>
+                      <a:noFill/>
+                    </a:lnT>
+                    <a:lnB>
+                      <a:noFill/>
+                    </a:lnB>
+                    <a:noFill/>
+                  </a:tcPr>
+                </a:tc>
+                <a:extLst>
+                  <a:ext uri="{0D108BD9-81ED-4DB2-BD59-A6C34878D82A}">
+                    <a16:rowId xmlns:a16="http://schemas.microsoft.com/office/drawing/2014/main" val="3190267609"/>
+                  </a:ext>
+                </a:extLst>
+              </a:tr>
+              <a:tr h="508281">
+                <a:tc>
+                  <a:txBody>
+                    <a:bodyPr/>
+                    <a:lstStyle/>
+                    <a:p>
+                      <a:pPr marL="0" marR="0">
+                        <a:lnSpc>
+                          <a:spcPct val="115000"/>
+                        </a:lnSpc>
+                        <a:spcAft>
+                          <a:spcPts val="800"/>
+                        </a:spcAft>
+                        <a:buNone/>
+                      </a:pPr>
+                      <a:r>
+                        <a:rPr lang="en-US" sz="1000" b="1" dirty="0">
+                          <a:effectLst/>
+                          <a:latin typeface="DM Sans" pitchFamily="2" charset="0"/>
+                          <a:ea typeface="Calibri" panose="020F0502020204030204" pitchFamily="34" charset="0"/>
+                          <a:cs typeface="Arial" panose="020B0604020202020204" pitchFamily="34" charset="0"/>
+                        </a:rPr>
+                        <a:t>[5] </a:t>
+                      </a:r>
+                    </a:p>
+                  </a:txBody>
+                  <a:tcPr marL="6940" marR="6940" marT="6940" marB="6940">
+                    <a:lnL>
+                      <a:noFill/>
+                    </a:lnL>
+                    <a:lnR>
+                      <a:noFill/>
+                    </a:lnR>
+                    <a:lnT>
+                      <a:noFill/>
+                    </a:lnT>
+                    <a:lnB>
+                      <a:noFill/>
+                    </a:lnB>
+                    <a:noFill/>
+                  </a:tcPr>
+                </a:tc>
+                <a:tc>
+                  <a:txBody>
+                    <a:bodyPr/>
+                    <a:lstStyle/>
+                    <a:p>
+                      <a:pPr marL="0" marR="0">
+                        <a:lnSpc>
+                          <a:spcPct val="115000"/>
+                        </a:lnSpc>
+                        <a:spcAft>
+                          <a:spcPts val="800"/>
+                        </a:spcAft>
+                        <a:buNone/>
+                      </a:pPr>
+                      <a:r>
+                        <a:rPr lang="en-US" sz="1000" b="1">
+                          <a:effectLst/>
+                          <a:latin typeface="DM Sans" pitchFamily="2" charset="0"/>
+                          <a:ea typeface="Calibri" panose="020F0502020204030204" pitchFamily="34" charset="0"/>
+                          <a:cs typeface="Arial" panose="020B0604020202020204" pitchFamily="34" charset="0"/>
+                        </a:rPr>
+                        <a:t>K. Easton, G. Nemhauser and M. Trick, "The traveling tournament problem description and benchmarks," </a:t>
+                      </a:r>
+                      <a:r>
+                        <a:rPr lang="en-US" sz="1000" b="1" i="1">
+                          <a:effectLst/>
+                          <a:latin typeface="DM Sans" pitchFamily="2" charset="0"/>
+                          <a:ea typeface="Calibri" panose="020F0502020204030204" pitchFamily="34" charset="0"/>
+                          <a:cs typeface="Arial" panose="020B0604020202020204" pitchFamily="34" charset="0"/>
+                        </a:rPr>
+                        <a:t>Principles and Practice of Constraint Programming, </a:t>
+                      </a:r>
+                      <a:r>
+                        <a:rPr lang="en-US" sz="1000" b="1">
+                          <a:effectLst/>
+                          <a:latin typeface="DM Sans" pitchFamily="2" charset="0"/>
+                          <a:ea typeface="Calibri" panose="020F0502020204030204" pitchFamily="34" charset="0"/>
+                          <a:cs typeface="Arial" panose="020B0604020202020204" pitchFamily="34" charset="0"/>
+                        </a:rPr>
+                        <a:t>pp. 580-584, 2001. </a:t>
+                      </a:r>
+                    </a:p>
+                  </a:txBody>
+                  <a:tcPr marL="6940" marR="6940" marT="6940" marB="6940">
+                    <a:lnL>
+                      <a:noFill/>
+                    </a:lnL>
+                    <a:lnR>
+                      <a:noFill/>
+                    </a:lnR>
+                    <a:lnT>
+                      <a:noFill/>
+                    </a:lnT>
+                    <a:lnB>
+                      <a:noFill/>
+                    </a:lnB>
+                    <a:noFill/>
+                  </a:tcPr>
+                </a:tc>
+                <a:extLst>
+                  <a:ext uri="{0D108BD9-81ED-4DB2-BD59-A6C34878D82A}">
+                    <a16:rowId xmlns:a16="http://schemas.microsoft.com/office/drawing/2014/main" val="1684665921"/>
+                  </a:ext>
+                </a:extLst>
+              </a:tr>
+              <a:tr h="508281">
+                <a:tc>
+                  <a:txBody>
+                    <a:bodyPr/>
+                    <a:lstStyle/>
+                    <a:p>
+                      <a:pPr marL="0" marR="0">
+                        <a:lnSpc>
+                          <a:spcPct val="115000"/>
+                        </a:lnSpc>
+                        <a:spcAft>
+                          <a:spcPts val="800"/>
+                        </a:spcAft>
+                        <a:buNone/>
+                      </a:pPr>
+                      <a:r>
+                        <a:rPr lang="en-US" sz="1000" b="1" dirty="0">
+                          <a:effectLst/>
+                          <a:latin typeface="DM Sans" pitchFamily="2" charset="0"/>
+                          <a:ea typeface="Calibri" panose="020F0502020204030204" pitchFamily="34" charset="0"/>
+                          <a:cs typeface="Arial" panose="020B0604020202020204" pitchFamily="34" charset="0"/>
+                        </a:rPr>
+                        <a:t>[6] </a:t>
+                      </a:r>
+                    </a:p>
+                  </a:txBody>
+                  <a:tcPr marL="6940" marR="6940" marT="6940" marB="6940">
+                    <a:lnL>
+                      <a:noFill/>
+                    </a:lnL>
+                    <a:lnR>
+                      <a:noFill/>
+                    </a:lnR>
+                    <a:lnT>
+                      <a:noFill/>
+                    </a:lnT>
+                    <a:lnB>
+                      <a:noFill/>
+                    </a:lnB>
+                    <a:noFill/>
+                  </a:tcPr>
+                </a:tc>
+                <a:tc>
+                  <a:txBody>
+                    <a:bodyPr/>
+                    <a:lstStyle/>
+                    <a:p>
+                      <a:pPr marL="0" marR="0">
+                        <a:lnSpc>
+                          <a:spcPct val="115000"/>
+                        </a:lnSpc>
+                        <a:spcAft>
+                          <a:spcPts val="800"/>
+                        </a:spcAft>
+                        <a:buNone/>
+                      </a:pPr>
+                      <a:r>
+                        <a:rPr lang="en-US" sz="1000" b="1" dirty="0">
+                          <a:effectLst/>
+                          <a:latin typeface="DM Sans" pitchFamily="2" charset="0"/>
+                          <a:ea typeface="Calibri" panose="020F0502020204030204" pitchFamily="34" charset="0"/>
+                          <a:cs typeface="Arial" panose="020B0604020202020204" pitchFamily="34" charset="0"/>
+                        </a:rPr>
+                        <a:t>G. Durán, M. Guajardo and J. Wolf-Yadlin, "Scheduling the Chilean soccer league by integer programming," </a:t>
+                      </a:r>
+                      <a:r>
+                        <a:rPr lang="en-US" sz="1000" b="1" i="1" dirty="0">
+                          <a:effectLst/>
+                          <a:latin typeface="DM Sans" pitchFamily="2" charset="0"/>
+                          <a:ea typeface="Calibri" panose="020F0502020204030204" pitchFamily="34" charset="0"/>
+                          <a:cs typeface="Arial" panose="020B0604020202020204" pitchFamily="34" charset="0"/>
+                        </a:rPr>
+                        <a:t>Interfaces, </a:t>
+                      </a:r>
+                      <a:r>
+                        <a:rPr lang="en-US" sz="1000" b="1" dirty="0">
+                          <a:effectLst/>
+                          <a:latin typeface="DM Sans" pitchFamily="2" charset="0"/>
+                          <a:ea typeface="Calibri" panose="020F0502020204030204" pitchFamily="34" charset="0"/>
+                          <a:cs typeface="Arial" panose="020B0604020202020204" pitchFamily="34" charset="0"/>
+                        </a:rPr>
+                        <a:t>vol. 37, no. 6, pp. 539-552, 2007. </a:t>
+                      </a:r>
+                    </a:p>
+                  </a:txBody>
+                  <a:tcPr marL="6940" marR="6940" marT="6940" marB="6940">
+                    <a:lnL>
+                      <a:noFill/>
+                    </a:lnL>
+                    <a:lnR>
+                      <a:noFill/>
+                    </a:lnR>
+                    <a:lnT>
+                      <a:noFill/>
+                    </a:lnT>
+                    <a:lnB>
+                      <a:noFill/>
+                    </a:lnB>
+                    <a:noFill/>
+                  </a:tcPr>
+                </a:tc>
+                <a:extLst>
+                  <a:ext uri="{0D108BD9-81ED-4DB2-BD59-A6C34878D82A}">
+                    <a16:rowId xmlns:a16="http://schemas.microsoft.com/office/drawing/2014/main" val="3484291916"/>
+                  </a:ext>
+                </a:extLst>
+              </a:tr>
+            </a:tbl>
+          </a:graphicData>
+        </a:graphic>
+      </p:graphicFrame>
+    </p:spTree>
+    <p:extLst>
+      <p:ext uri="{BB962C8B-B14F-4D97-AF65-F5344CB8AC3E}">
+        <p14:creationId xmlns:p14="http://schemas.microsoft.com/office/powerpoint/2010/main" val="83040034"/>
+      </p:ext>
+    </p:extLst>
+  </p:cSld>
+  <p:clrMapOvr>
+    <a:masterClrMapping/>
+  </p:clrMapOvr>
+</p:sld>
+</file>
+
+<file path=ppt/slides/slide22.xml><?xml version="1.0" encoding="utf-8"?>
 <p:sld xmlns:a="http://schemas.openxmlformats.org/drawingml/2006/main" xmlns:r="http://schemas.openxmlformats.org/officeDocument/2006/relationships" xmlns:p="http://schemas.openxmlformats.org/presentationml/2006/main">
   <p:cSld>
     <p:spTree>
@@ -30721,7 +31640,7 @@
 </p:sld>
 </file>
 
-<file path=ppt/slides/slide22.xml><?xml version="1.0" encoding="utf-8"?>
+<file path=ppt/slides/slide23.xml><?xml version="1.0" encoding="utf-8"?>
 <p:sld xmlns:a="http://schemas.openxmlformats.org/drawingml/2006/main" xmlns:r="http://schemas.openxmlformats.org/officeDocument/2006/relationships" xmlns:p="http://schemas.openxmlformats.org/presentationml/2006/main">
   <p:cSld>
     <p:bg>
@@ -30910,7 +31829,7 @@
             <a:pPr lvl="0"/>
             <a:r>
               <a:rPr lang="en-US" dirty="0"/>
-              <a:t>The Origin Story </a:t>
+              <a:t>The origin of the story </a:t>
             </a:r>
             <a:endParaRPr dirty="0"/>
           </a:p>
@@ -30934,8 +31853,8 @@
         </p:nvSpPr>
         <p:spPr bwMode="auto">
           <a:xfrm>
-            <a:off x="720000" y="471175"/>
-            <a:ext cx="8050620" cy="4201150"/>
+            <a:off x="512956" y="866657"/>
+            <a:ext cx="8302269" cy="3831818"/>
           </a:xfrm>
           <a:prstGeom prst="rect">
             <a:avLst/>
@@ -30983,7 +31902,7 @@
           </a:bodyPr>
           <a:lstStyle/>
           <a:p>
-            <a:pPr marL="285750" marR="0" lvl="0" indent="-285750" algn="l" defTabSz="914400" rtl="0" eaLnBrk="0" fontAlgn="base" latinLnBrk="0" hangingPunct="0">
+            <a:pPr marL="0" marR="0" lvl="0" indent="0" algn="l" defTabSz="914400" rtl="0" eaLnBrk="0" fontAlgn="base" latinLnBrk="0" hangingPunct="0">
               <a:lnSpc>
                 <a:spcPct val="150000"/>
               </a:lnSpc>
@@ -30995,8 +31914,6 @@
               </a:spcAft>
               <a:buClrTx/>
               <a:buSzTx/>
-              <a:buFont typeface="Arial" panose="020B0604020202020204" pitchFamily="34" charset="0"/>
-              <a:buChar char="•"/>
               <a:tabLst/>
             </a:pPr>
             <a:endParaRPr kumimoji="0" lang="en-US" altLang="en-US" sz="1600" b="1" i="0" u="none" strike="noStrike" cap="none" normalizeH="0" baseline="0" dirty="0">
@@ -31011,31 +31928,7 @@
             </a:endParaRPr>
           </a:p>
           <a:p>
-            <a:pPr marL="285750" marR="0" lvl="0" indent="-285750" algn="l" defTabSz="914400" rtl="0" eaLnBrk="0" fontAlgn="base" latinLnBrk="0" hangingPunct="0">
-              <a:lnSpc>
-                <a:spcPct val="150000"/>
-              </a:lnSpc>
-              <a:spcBef>
-                <a:spcPct val="0"/>
-              </a:spcBef>
-              <a:spcAft>
-                <a:spcPct val="0"/>
-              </a:spcAft>
-              <a:buClrTx/>
-              <a:buSzTx/>
-              <a:buFont typeface="Arial" panose="020B0604020202020204" pitchFamily="34" charset="0"/>
-              <a:buChar char="•"/>
-              <a:tabLst/>
-            </a:pPr>
-            <a:endParaRPr lang="en-US" altLang="en-US" sz="1600" b="1" dirty="0">
-              <a:solidFill>
-                <a:schemeClr val="tx1"/>
-              </a:solidFill>
-              <a:latin typeface="DM Sans" pitchFamily="2" charset="0"/>
-            </a:endParaRPr>
-          </a:p>
-          <a:p>
-            <a:pPr marL="285750" marR="0" lvl="0" indent="-285750" algn="l" defTabSz="914400" rtl="0" eaLnBrk="0" fontAlgn="base" latinLnBrk="0" hangingPunct="0">
+            <a:pPr marL="285750" marR="0" lvl="0" indent="-285750" algn="l" defTabSz="914400" eaLnBrk="0" fontAlgn="base" latinLnBrk="0" hangingPunct="0">
               <a:lnSpc>
                 <a:spcPct val="150000"/>
               </a:lnSpc>
@@ -31052,35 +31945,14 @@
               <a:tabLst/>
             </a:pPr>
             <a:r>
-              <a:rPr kumimoji="0" lang="en-US" altLang="en-US" sz="1600" b="1" i="0" u="none" strike="noStrike" cap="none" normalizeH="0" baseline="0" dirty="0">
-                <a:ln>
-                  <a:noFill/>
-                </a:ln>
+              <a:rPr lang="en-US" altLang="en-US" sz="1600" b="1" dirty="0">
                 <a:solidFill>
                   <a:schemeClr val="tx1"/>
                 </a:solidFill>
-                <a:effectLst/>
                 <a:latin typeface="DM Sans" pitchFamily="2" charset="0"/>
               </a:rPr>
-              <a:t>The instability began during the 2018/2019 season, triggered by Egypt's emergency hosting of the 2019 AFCON in June.</a:t>
+              <a:t>For years, league scheduling relied on manual planning, quietly accumulating issues that became impossible to ignore during Egypt’s emergency hosting of AFCON 2019.</a:t>
             </a:r>
-          </a:p>
-          <a:p>
-            <a:pPr marL="742950" lvl="1" indent="-285750" algn="l" eaLnBrk="0" fontAlgn="base" hangingPunct="0">
-              <a:lnSpc>
-                <a:spcPct val="150000"/>
-              </a:lnSpc>
-              <a:spcBef>
-                <a:spcPct val="0"/>
-              </a:spcBef>
-              <a:spcAft>
-                <a:spcPct val="0"/>
-              </a:spcAft>
-              <a:buClrTx/>
-              <a:buSzTx/>
-              <a:buFont typeface="Wingdings" panose="05000000000000000000" pitchFamily="2" charset="2"/>
-              <a:buChar char="Ø"/>
-            </a:pPr>
             <a:r>
               <a:rPr kumimoji="0" lang="en-US" altLang="en-US" sz="1600" b="1" i="0" u="none" strike="noStrike" cap="none" normalizeH="0" baseline="0" dirty="0">
                 <a:ln>
@@ -32153,7 +33025,7 @@
                 <a:effectLst/>
                 <a:latin typeface="DM Sans" panose="020B0604020202020204" charset="0"/>
               </a:rPr>
-              <a:t>This chart illustrates the 2020/2021 crisis peak, comparing the disparity in matches played by five teams at the same point in the season.</a:t>
+              <a:t>This chart illustrates the 2020/2021 problem’s peak, comparing the disparity in matches played by five teams at the same point in the season.</a:t>
             </a:r>
             <a:endParaRPr lang="en-US" sz="1600" b="1" dirty="0">
               <a:solidFill>
@@ -35064,7 +35936,7 @@
         <p:spPr>
           <a:xfrm>
             <a:off x="1024796" y="1439100"/>
-            <a:ext cx="5246463" cy="442500"/>
+            <a:ext cx="6401916" cy="442500"/>
           </a:xfrm>
           <a:prstGeom prst="roundRect">
             <a:avLst>
@@ -35092,6 +35964,7 @@
                 <a:solidFill>
                   <a:schemeClr val="tx1"/>
                 </a:solidFill>
+                <a:latin typeface="Montserrat" panose="00000500000000000000" pitchFamily="2" charset="0"/>
               </a:rPr>
               <a:t>An Optimization-Based System.</a:t>
             </a:r>
@@ -35099,7 +35972,7 @@
               <a:solidFill>
                 <a:schemeClr val="tx1"/>
               </a:solidFill>
-              <a:latin typeface="Montserrat ExtraBold"/>
+              <a:latin typeface="Montserrat" panose="00000500000000000000" pitchFamily="2" charset="0"/>
               <a:ea typeface="Montserrat ExtraBold"/>
               <a:cs typeface="Montserrat ExtraBold"/>
               <a:sym typeface="Montserrat ExtraBold"/>
@@ -35144,6 +36017,7 @@
                 <a:solidFill>
                   <a:schemeClr val="tx1"/>
                 </a:solidFill>
+                <a:latin typeface="Montserrat" panose="00000500000000000000" pitchFamily="2" charset="0"/>
               </a:rPr>
               <a:t>Input</a:t>
             </a:r>
@@ -35151,7 +36025,7 @@
               <a:solidFill>
                 <a:schemeClr val="tx1"/>
               </a:solidFill>
-              <a:latin typeface="Montserrat ExtraBold"/>
+              <a:latin typeface="Montserrat" panose="00000500000000000000" pitchFamily="2" charset="0"/>
               <a:ea typeface="Montserrat ExtraBold"/>
               <a:cs typeface="Montserrat ExtraBold"/>
               <a:sym typeface="Montserrat ExtraBold"/>
@@ -35247,14 +36121,15 @@
                 <a:solidFill>
                   <a:schemeClr val="tx1"/>
                 </a:solidFill>
+                <a:latin typeface="Montserrat" panose="00000500000000000000" pitchFamily="2" charset="0"/>
               </a:rPr>
-              <a:t>Engine</a:t>
+              <a:t>Model</a:t>
             </a:r>
             <a:endParaRPr sz="2200" b="1" dirty="0">
               <a:solidFill>
                 <a:schemeClr val="tx1"/>
               </a:solidFill>
-              <a:latin typeface="Montserrat ExtraBold"/>
+              <a:latin typeface="Montserrat" panose="00000500000000000000" pitchFamily="2" charset="0"/>
               <a:ea typeface="Montserrat ExtraBold"/>
               <a:cs typeface="Montserrat ExtraBold"/>
               <a:sym typeface="Montserrat ExtraBold"/>
@@ -35350,6 +36225,7 @@
                 <a:solidFill>
                   <a:schemeClr val="tx1"/>
                 </a:solidFill>
+                <a:latin typeface="Montserrat" panose="00000500000000000000" pitchFamily="2" charset="0"/>
               </a:rPr>
               <a:t>Output</a:t>
             </a:r>
@@ -35357,7 +36233,7 @@
               <a:solidFill>
                 <a:schemeClr val="tx1"/>
               </a:solidFill>
-              <a:latin typeface="Montserrat ExtraBold"/>
+              <a:latin typeface="Montserrat" panose="00000500000000000000" pitchFamily="2" charset="0"/>
               <a:ea typeface="Montserrat ExtraBold"/>
               <a:cs typeface="Montserrat ExtraBold"/>
               <a:sym typeface="Montserrat ExtraBold"/>
@@ -35401,7 +36277,7 @@
                   <a:schemeClr val="tx1"/>
                 </a:solidFill>
               </a:rPr>
-              <a:t>An optimal schedule that balances efficiency and fairness.</a:t>
+              <a:t>An efficient schedule that balances efficiency and fairness.</a:t>
             </a:r>
             <a:endParaRPr dirty="0">
               <a:solidFill>
@@ -36702,12 +37578,11 @@
 </file>
 
 <file path=customXml/item1.xml><?xml version="1.0" encoding="utf-8"?>
-<?mso-contentType ?>
-<FormTemplates xmlns="http://schemas.microsoft.com/sharepoint/v3/contenttype/forms">
-  <Display>DocumentLibraryForm</Display>
-  <Edit>DocumentLibraryForm</Edit>
-  <New>DocumentLibraryForm</New>
-</FormTemplates>
+<p:properties xmlns:p="http://schemas.microsoft.com/office/2006/metadata/properties" xmlns:xsi="http://www.w3.org/2001/XMLSchema-instance" xmlns:pc="http://schemas.microsoft.com/office/infopath/2007/PartnerControls">
+  <documentManagement>
+    <_activity xmlns="9427ba3f-bf6b-4e36-982f-401b240078b5" xsi:nil="true"/>
+  </documentManagement>
+</p:properties>
 </file>
 
 <file path=customXml/item2.xml><?xml version="1.0" encoding="utf-8"?>
@@ -36900,17 +37775,27 @@
 </file>
 
 <file path=customXml/item3.xml><?xml version="1.0" encoding="utf-8"?>
-<p:properties xmlns:p="http://schemas.microsoft.com/office/2006/metadata/properties" xmlns:xsi="http://www.w3.org/2001/XMLSchema-instance" xmlns:pc="http://schemas.microsoft.com/office/infopath/2007/PartnerControls">
-  <documentManagement>
-    <_activity xmlns="9427ba3f-bf6b-4e36-982f-401b240078b5" xsi:nil="true"/>
-  </documentManagement>
-</p:properties>
+<?mso-contentType ?>
+<FormTemplates xmlns="http://schemas.microsoft.com/sharepoint/v3/contenttype/forms">
+  <Display>DocumentLibraryForm</Display>
+  <Edit>DocumentLibraryForm</Edit>
+  <New>DocumentLibraryForm</New>
+</FormTemplates>
 </file>
 
 <file path=customXml/itemProps1.xml><?xml version="1.0" encoding="utf-8"?>
-<ds:datastoreItem xmlns:ds="http://schemas.openxmlformats.org/officeDocument/2006/customXml" ds:itemID="{4309E11F-D857-4267-A6D9-2945B8F42689}">
+<ds:datastoreItem xmlns:ds="http://schemas.openxmlformats.org/officeDocument/2006/customXml" ds:itemID="{672E6D98-677C-41B8-8A0A-E214B4F1B9ED}">
   <ds:schemaRefs>
-    <ds:schemaRef ds:uri="http://schemas.microsoft.com/sharepoint/v3/contenttype/forms"/>
+    <ds:schemaRef ds:uri="http://schemas.openxmlformats.org/package/2006/metadata/core-properties"/>
+    <ds:schemaRef ds:uri="http://purl.org/dc/dcmitype/"/>
+    <ds:schemaRef ds:uri="http://schemas.microsoft.com/office/2006/metadata/properties"/>
+    <ds:schemaRef ds:uri="http://purl.org/dc/elements/1.1/"/>
+    <ds:schemaRef ds:uri="9427ba3f-bf6b-4e36-982f-401b240078b5"/>
+    <ds:schemaRef ds:uri="http://schemas.microsoft.com/office/2006/documentManagement/types"/>
+    <ds:schemaRef ds:uri="ed82aeb9-b910-4c50-992f-22dbdd50696f"/>
+    <ds:schemaRef ds:uri="http://www.w3.org/XML/1998/namespace"/>
+    <ds:schemaRef ds:uri="http://schemas.microsoft.com/office/infopath/2007/PartnerControls"/>
+    <ds:schemaRef ds:uri="http://purl.org/dc/terms/"/>
   </ds:schemaRefs>
 </ds:datastoreItem>
 </file>
@@ -36935,18 +37820,9 @@
 </file>
 
 <file path=customXml/itemProps3.xml><?xml version="1.0" encoding="utf-8"?>
-<ds:datastoreItem xmlns:ds="http://schemas.openxmlformats.org/officeDocument/2006/customXml" ds:itemID="{672E6D98-677C-41B8-8A0A-E214B4F1B9ED}">
+<ds:datastoreItem xmlns:ds="http://schemas.openxmlformats.org/officeDocument/2006/customXml" ds:itemID="{4309E11F-D857-4267-A6D9-2945B8F42689}">
   <ds:schemaRefs>
-    <ds:schemaRef ds:uri="http://schemas.openxmlformats.org/package/2006/metadata/core-properties"/>
-    <ds:schemaRef ds:uri="http://purl.org/dc/dcmitype/"/>
-    <ds:schemaRef ds:uri="http://schemas.microsoft.com/office/2006/metadata/properties"/>
-    <ds:schemaRef ds:uri="http://purl.org/dc/elements/1.1/"/>
-    <ds:schemaRef ds:uri="9427ba3f-bf6b-4e36-982f-401b240078b5"/>
-    <ds:schemaRef ds:uri="http://schemas.microsoft.com/office/2006/documentManagement/types"/>
-    <ds:schemaRef ds:uri="ed82aeb9-b910-4c50-992f-22dbdd50696f"/>
-    <ds:schemaRef ds:uri="http://www.w3.org/XML/1998/namespace"/>
-    <ds:schemaRef ds:uri="http://schemas.microsoft.com/office/infopath/2007/PartnerControls"/>
-    <ds:schemaRef ds:uri="http://purl.org/dc/terms/"/>
+    <ds:schemaRef ds:uri="http://schemas.microsoft.com/sharepoint/v3/contenttype/forms"/>
   </ds:schemaRefs>
 </ds:datastoreItem>
 </file>
</xml_diff>